<commit_message>
fix: polish final defense presentation layout
</commit_message>
<xml_diff>
--- a/docs/final/Wealthora_CSE215_Project_Defense.pptx
+++ b/docs/final/Wealthora_CSE215_Project_Defense.pptx
@@ -2,29 +2,29 @@
 <file path=ppt/presentation.xml><?xml version="1.0" encoding="utf-8"?>
 <p:presentation xmlns:p="http://schemas.openxmlformats.org/presentationml/2006/main">
   <p:sldMasterIdLst>
-    <p:sldMasterId xmlns:r="http://schemas.openxmlformats.org/officeDocument/2006/relationships" id="2147483648" r:id="R579f3f97d2604798"/>
+    <p:sldMasterId xmlns:r="http://schemas.openxmlformats.org/officeDocument/2006/relationships" id="2147483648" r:id="Reb2430909901407a"/>
   </p:sldMasterIdLst>
   <p:notesMasterIdLst>
-    <p:notesMasterId xmlns:r="http://schemas.openxmlformats.org/officeDocument/2006/relationships" r:id="Rb77d3e1a245b4019"/>
+    <p:notesMasterId xmlns:r="http://schemas.openxmlformats.org/officeDocument/2006/relationships" r:id="Re6bddd6e09394998"/>
   </p:notesMasterIdLst>
   <p:sldIdLst>
-    <p:sldId xmlns:r="http://schemas.openxmlformats.org/officeDocument/2006/relationships" id="256" r:id="Rff798c825831450e"/>
-    <p:sldId xmlns:r="http://schemas.openxmlformats.org/officeDocument/2006/relationships" id="257" r:id="R01841a6648ce4ccd"/>
-    <p:sldId xmlns:r="http://schemas.openxmlformats.org/officeDocument/2006/relationships" id="258" r:id="R81aa5865de2f4b9e"/>
-    <p:sldId xmlns:r="http://schemas.openxmlformats.org/officeDocument/2006/relationships" id="259" r:id="R8891b8e4aee54241"/>
-    <p:sldId xmlns:r="http://schemas.openxmlformats.org/officeDocument/2006/relationships" id="260" r:id="R4ce26ba4fe6c4e00"/>
-    <p:sldId xmlns:r="http://schemas.openxmlformats.org/officeDocument/2006/relationships" id="261" r:id="Rdbcb3575eb4d49bd"/>
-    <p:sldId xmlns:r="http://schemas.openxmlformats.org/officeDocument/2006/relationships" id="262" r:id="Rcfb2dc24ad9c4cdd"/>
-    <p:sldId xmlns:r="http://schemas.openxmlformats.org/officeDocument/2006/relationships" id="263" r:id="Rdb11ef8d558447a8"/>
-    <p:sldId xmlns:r="http://schemas.openxmlformats.org/officeDocument/2006/relationships" id="264" r:id="Rbf8c1782d0ac48f5"/>
-    <p:sldId xmlns:r="http://schemas.openxmlformats.org/officeDocument/2006/relationships" id="265" r:id="Rd5e0734cea054172"/>
-    <p:sldId xmlns:r="http://schemas.openxmlformats.org/officeDocument/2006/relationships" id="266" r:id="R60da91c83a164c7b"/>
-    <p:sldId xmlns:r="http://schemas.openxmlformats.org/officeDocument/2006/relationships" id="267" r:id="R424655aa57ce4a6f"/>
-    <p:sldId xmlns:r="http://schemas.openxmlformats.org/officeDocument/2006/relationships" id="268" r:id="R81db54ac60354726"/>
-    <p:sldId xmlns:r="http://schemas.openxmlformats.org/officeDocument/2006/relationships" id="269" r:id="R787c2fa9ef7644bf"/>
-    <p:sldId xmlns:r="http://schemas.openxmlformats.org/officeDocument/2006/relationships" id="270" r:id="Ra61eda7c486f4788"/>
-    <p:sldId xmlns:r="http://schemas.openxmlformats.org/officeDocument/2006/relationships" id="271" r:id="Reeac21c1e09e4199"/>
-    <p:sldId xmlns:r="http://schemas.openxmlformats.org/officeDocument/2006/relationships" id="272" r:id="Rb9956d281b794ab0"/>
+    <p:sldId xmlns:r="http://schemas.openxmlformats.org/officeDocument/2006/relationships" id="256" r:id="Rfcf93a3727e24f20"/>
+    <p:sldId xmlns:r="http://schemas.openxmlformats.org/officeDocument/2006/relationships" id="257" r:id="R50736335ce614437"/>
+    <p:sldId xmlns:r="http://schemas.openxmlformats.org/officeDocument/2006/relationships" id="258" r:id="Rdd42708083474233"/>
+    <p:sldId xmlns:r="http://schemas.openxmlformats.org/officeDocument/2006/relationships" id="259" r:id="R24575255837c4086"/>
+    <p:sldId xmlns:r="http://schemas.openxmlformats.org/officeDocument/2006/relationships" id="260" r:id="R1fdf859123d84ace"/>
+    <p:sldId xmlns:r="http://schemas.openxmlformats.org/officeDocument/2006/relationships" id="261" r:id="R3fabc98ce7394a5a"/>
+    <p:sldId xmlns:r="http://schemas.openxmlformats.org/officeDocument/2006/relationships" id="262" r:id="R6e138246fb444596"/>
+    <p:sldId xmlns:r="http://schemas.openxmlformats.org/officeDocument/2006/relationships" id="263" r:id="Rf47148c103c84b2d"/>
+    <p:sldId xmlns:r="http://schemas.openxmlformats.org/officeDocument/2006/relationships" id="264" r:id="Rcc63ba99350841c2"/>
+    <p:sldId xmlns:r="http://schemas.openxmlformats.org/officeDocument/2006/relationships" id="265" r:id="Rcad4ec36e8a7445b"/>
+    <p:sldId xmlns:r="http://schemas.openxmlformats.org/officeDocument/2006/relationships" id="266" r:id="Raf70d1f0f3b1461e"/>
+    <p:sldId xmlns:r="http://schemas.openxmlformats.org/officeDocument/2006/relationships" id="267" r:id="Rc0b0230138d44a0a"/>
+    <p:sldId xmlns:r="http://schemas.openxmlformats.org/officeDocument/2006/relationships" id="268" r:id="R0df9b046b3b347d3"/>
+    <p:sldId xmlns:r="http://schemas.openxmlformats.org/officeDocument/2006/relationships" id="269" r:id="Rda91872062f143ee"/>
+    <p:sldId xmlns:r="http://schemas.openxmlformats.org/officeDocument/2006/relationships" id="270" r:id="Rbe51fbf05d624780"/>
+    <p:sldId xmlns:r="http://schemas.openxmlformats.org/officeDocument/2006/relationships" id="271" r:id="Rec20fb4802e5467f"/>
+    <p:sldId xmlns:r="http://schemas.openxmlformats.org/officeDocument/2006/relationships" id="272" r:id="R78ebe2281edb4dac"/>
   </p:sldIdLst>
   <p:sldSz cx="12192000" cy="6858000"/>
   <p:notesSz cx="6858000" cy="9144000"/>
@@ -2176,7 +2176,7 @@
   </p:cSld>
   <p:clrMap bg1="lt1" tx1="dk1" bg2="lt2" tx2="dk2" accent1="accent1" accent2="accent2" accent3="accent3" accent4="accent4" accent5="accent5" accent6="accent6" hlink="hlink" folHlink="folHlink"/>
   <p:sldLayoutIdLst>
-    <p:sldLayoutId xmlns:r="http://schemas.openxmlformats.org/officeDocument/2006/relationships" id="2147483649" r:id="Rfa9dae09d5c940d6"/>
+    <p:sldLayoutId xmlns:r="http://schemas.openxmlformats.org/officeDocument/2006/relationships" id="2147483649" r:id="R7ca5ce1d7cff411a"/>
   </p:sldLayoutIdLst>
   <p:txStyles>
     <p:titleStyle>
@@ -3550,14 +3550,14 @@
           <a:p xmlns:a="http://schemas.openxmlformats.org/drawingml/2006/main">
             <a:pPr algn="l">
               <a:buNone/>
-              <a:defRPr sz="3600" b="1" i="0">
-                <a:solidFill>
-                  <a:srgbClr val="17212B"/>
-                </a:solidFill>
-              </a:defRPr>
-            </a:pPr>
-            <a:r>
-              <a:rPr sz="3600" b="1" i="0">
+              <a:defRPr sz="3000" b="1" i="0">
+                <a:solidFill>
+                  <a:srgbClr val="17212B"/>
+                </a:solidFill>
+              </a:defRPr>
+            </a:pPr>
+            <a:r>
+              <a:rPr sz="3000" b="1" i="0">
                 <a:solidFill>
                   <a:srgbClr val="17212B"/>
                 </a:solidFill>
@@ -4707,14 +4707,14 @@
           <a:p xmlns:a="http://schemas.openxmlformats.org/drawingml/2006/main">
             <a:pPr algn="l">
               <a:buNone/>
-              <a:defRPr sz="3600" b="1" i="0">
-                <a:solidFill>
-                  <a:srgbClr val="17212B"/>
-                </a:solidFill>
-              </a:defRPr>
-            </a:pPr>
-            <a:r>
-              <a:rPr sz="3600" b="1" i="0">
+              <a:defRPr sz="3000" b="1" i="0">
+                <a:solidFill>
+                  <a:srgbClr val="17212B"/>
+                </a:solidFill>
+              </a:defRPr>
+            </a:pPr>
+            <a:r>
+              <a:rPr sz="3000" b="1" i="0">
                 <a:solidFill>
                   <a:srgbClr val="17212B"/>
                 </a:solidFill>
@@ -6236,14 +6236,14 @@
           <a:p xmlns:a="http://schemas.openxmlformats.org/drawingml/2006/main">
             <a:pPr algn="l">
               <a:buNone/>
-              <a:defRPr sz="3600" b="1" i="0">
-                <a:solidFill>
-                  <a:srgbClr val="17212B"/>
-                </a:solidFill>
-              </a:defRPr>
-            </a:pPr>
-            <a:r>
-              <a:rPr sz="3600" b="1" i="0">
+              <a:defRPr sz="3000" b="1" i="0">
+                <a:solidFill>
+                  <a:srgbClr val="17212B"/>
+                </a:solidFill>
+              </a:defRPr>
+            </a:pPr>
+            <a:r>
+              <a:rPr sz="3000" b="1" i="0">
                 <a:solidFill>
                   <a:srgbClr val="17212B"/>
                 </a:solidFill>
@@ -6557,14 +6557,14 @@
           <a:p xmlns:a="http://schemas.openxmlformats.org/drawingml/2006/main">
             <a:pPr algn="l">
               <a:buNone/>
-              <a:defRPr sz="1350" b="1" i="0">
-                <a:solidFill>
-                  <a:srgbClr val="17212B"/>
-                </a:solidFill>
-              </a:defRPr>
-            </a:pPr>
-            <a:r>
-              <a:rPr sz="1350" b="1" i="0">
+              <a:defRPr sz="1275" b="1" i="0">
+                <a:solidFill>
+                  <a:srgbClr val="17212B"/>
+                </a:solidFill>
+              </a:defRPr>
+            </a:pPr>
+            <a:r>
+              <a:rPr sz="1275" b="1" i="0">
                 <a:solidFill>
                   <a:srgbClr val="17212B"/>
                 </a:solidFill>
@@ -6608,14 +6608,14 @@
           <a:p xmlns:a="http://schemas.openxmlformats.org/drawingml/2006/main">
             <a:pPr algn="l">
               <a:buNone/>
-              <a:defRPr sz="1275" b="1" i="0">
+              <a:defRPr sz="1200" b="1" i="0">
                 <a:solidFill>
                   <a:srgbClr val="16785B"/>
                 </a:solidFill>
               </a:defRPr>
             </a:pPr>
             <a:r>
-              <a:rPr sz="1275" b="1" i="0">
+              <a:rPr sz="1200" b="1" i="0">
                 <a:solidFill>
                   <a:srgbClr val="16785B"/>
                 </a:solidFill>
@@ -6659,14 +6659,14 @@
           <a:p xmlns:a="http://schemas.openxmlformats.org/drawingml/2006/main">
             <a:pPr algn="l">
               <a:buNone/>
-              <a:defRPr sz="1275" b="0" i="0">
-                <a:solidFill>
-                  <a:srgbClr val="17212B"/>
-                </a:solidFill>
-              </a:defRPr>
-            </a:pPr>
-            <a:r>
-              <a:rPr sz="1275" b="0" i="0">
+              <a:defRPr sz="1200" b="0" i="0">
+                <a:solidFill>
+                  <a:srgbClr val="17212B"/>
+                </a:solidFill>
+              </a:defRPr>
+            </a:pPr>
+            <a:r>
+              <a:rPr sz="1200" b="0" i="0">
                 <a:solidFill>
                   <a:srgbClr val="17212B"/>
                 </a:solidFill>
@@ -6743,14 +6743,14 @@
           <a:p xmlns:a="http://schemas.openxmlformats.org/drawingml/2006/main">
             <a:pPr algn="l">
               <a:buNone/>
-              <a:defRPr sz="1350" b="1" i="0">
-                <a:solidFill>
-                  <a:srgbClr val="17212B"/>
-                </a:solidFill>
-              </a:defRPr>
-            </a:pPr>
-            <a:r>
-              <a:rPr sz="1350" b="1" i="0">
+              <a:defRPr sz="1275" b="1" i="0">
+                <a:solidFill>
+                  <a:srgbClr val="17212B"/>
+                </a:solidFill>
+              </a:defRPr>
+            </a:pPr>
+            <a:r>
+              <a:rPr sz="1275" b="1" i="0">
                 <a:solidFill>
                   <a:srgbClr val="17212B"/>
                 </a:solidFill>
@@ -6794,14 +6794,14 @@
           <a:p xmlns:a="http://schemas.openxmlformats.org/drawingml/2006/main">
             <a:pPr algn="l">
               <a:buNone/>
-              <a:defRPr sz="1275" b="1" i="0">
+              <a:defRPr sz="1200" b="1" i="0">
                 <a:solidFill>
                   <a:srgbClr val="16785B"/>
                 </a:solidFill>
               </a:defRPr>
             </a:pPr>
             <a:r>
-              <a:rPr sz="1275" b="1" i="0">
+              <a:rPr sz="1200" b="1" i="0">
                 <a:solidFill>
                   <a:srgbClr val="16785B"/>
                 </a:solidFill>
@@ -6845,14 +6845,14 @@
           <a:p xmlns:a="http://schemas.openxmlformats.org/drawingml/2006/main">
             <a:pPr algn="l">
               <a:buNone/>
-              <a:defRPr sz="1275" b="0" i="0">
-                <a:solidFill>
-                  <a:srgbClr val="17212B"/>
-                </a:solidFill>
-              </a:defRPr>
-            </a:pPr>
-            <a:r>
-              <a:rPr sz="1275" b="0" i="0">
+              <a:defRPr sz="1200" b="0" i="0">
+                <a:solidFill>
+                  <a:srgbClr val="17212B"/>
+                </a:solidFill>
+              </a:defRPr>
+            </a:pPr>
+            <a:r>
+              <a:rPr sz="1200" b="0" i="0">
                 <a:solidFill>
                   <a:srgbClr val="17212B"/>
                 </a:solidFill>
@@ -6929,14 +6929,14 @@
           <a:p xmlns:a="http://schemas.openxmlformats.org/drawingml/2006/main">
             <a:pPr algn="l">
               <a:buNone/>
-              <a:defRPr sz="1350" b="1" i="0">
-                <a:solidFill>
-                  <a:srgbClr val="17212B"/>
-                </a:solidFill>
-              </a:defRPr>
-            </a:pPr>
-            <a:r>
-              <a:rPr sz="1350" b="1" i="0">
+              <a:defRPr sz="1275" b="1" i="0">
+                <a:solidFill>
+                  <a:srgbClr val="17212B"/>
+                </a:solidFill>
+              </a:defRPr>
+            </a:pPr>
+            <a:r>
+              <a:rPr sz="1275" b="1" i="0">
                 <a:solidFill>
                   <a:srgbClr val="17212B"/>
                 </a:solidFill>
@@ -6980,14 +6980,14 @@
           <a:p xmlns:a="http://schemas.openxmlformats.org/drawingml/2006/main">
             <a:pPr algn="l">
               <a:buNone/>
-              <a:defRPr sz="1275" b="1" i="0">
+              <a:defRPr sz="1200" b="1" i="0">
                 <a:solidFill>
                   <a:srgbClr val="16785B"/>
                 </a:solidFill>
               </a:defRPr>
             </a:pPr>
             <a:r>
-              <a:rPr sz="1275" b="1" i="0">
+              <a:rPr sz="1200" b="1" i="0">
                 <a:solidFill>
                   <a:srgbClr val="16785B"/>
                 </a:solidFill>
@@ -7031,14 +7031,14 @@
           <a:p xmlns:a="http://schemas.openxmlformats.org/drawingml/2006/main">
             <a:pPr algn="l">
               <a:buNone/>
-              <a:defRPr sz="1275" b="0" i="0">
-                <a:solidFill>
-                  <a:srgbClr val="17212B"/>
-                </a:solidFill>
-              </a:defRPr>
-            </a:pPr>
-            <a:r>
-              <a:rPr sz="1275" b="0" i="0">
+              <a:defRPr sz="1200" b="0" i="0">
+                <a:solidFill>
+                  <a:srgbClr val="17212B"/>
+                </a:solidFill>
+              </a:defRPr>
+            </a:pPr>
+            <a:r>
+              <a:rPr sz="1200" b="0" i="0">
                 <a:solidFill>
                   <a:srgbClr val="17212B"/>
                 </a:solidFill>
@@ -7115,14 +7115,14 @@
           <a:p xmlns:a="http://schemas.openxmlformats.org/drawingml/2006/main">
             <a:pPr algn="l">
               <a:buNone/>
-              <a:defRPr sz="1350" b="1" i="0">
-                <a:solidFill>
-                  <a:srgbClr val="17212B"/>
-                </a:solidFill>
-              </a:defRPr>
-            </a:pPr>
-            <a:r>
-              <a:rPr sz="1350" b="1" i="0">
+              <a:defRPr sz="1275" b="1" i="0">
+                <a:solidFill>
+                  <a:srgbClr val="17212B"/>
+                </a:solidFill>
+              </a:defRPr>
+            </a:pPr>
+            <a:r>
+              <a:rPr sz="1275" b="1" i="0">
                 <a:solidFill>
                   <a:srgbClr val="17212B"/>
                 </a:solidFill>
@@ -7166,14 +7166,14 @@
           <a:p xmlns:a="http://schemas.openxmlformats.org/drawingml/2006/main">
             <a:pPr algn="l">
               <a:buNone/>
-              <a:defRPr sz="1275" b="1" i="0">
+              <a:defRPr sz="1200" b="1" i="0">
                 <a:solidFill>
                   <a:srgbClr val="16785B"/>
                 </a:solidFill>
               </a:defRPr>
             </a:pPr>
             <a:r>
-              <a:rPr sz="1275" b="1" i="0">
+              <a:rPr sz="1200" b="1" i="0">
                 <a:solidFill>
                   <a:srgbClr val="16785B"/>
                 </a:solidFill>
@@ -7217,14 +7217,14 @@
           <a:p xmlns:a="http://schemas.openxmlformats.org/drawingml/2006/main">
             <a:pPr algn="l">
               <a:buNone/>
-              <a:defRPr sz="1275" b="0" i="0">
-                <a:solidFill>
-                  <a:srgbClr val="17212B"/>
-                </a:solidFill>
-              </a:defRPr>
-            </a:pPr>
-            <a:r>
-              <a:rPr sz="1275" b="0" i="0">
+              <a:defRPr sz="1200" b="0" i="0">
+                <a:solidFill>
+                  <a:srgbClr val="17212B"/>
+                </a:solidFill>
+              </a:defRPr>
+            </a:pPr>
+            <a:r>
+              <a:rPr sz="1200" b="0" i="0">
                 <a:solidFill>
                   <a:srgbClr val="17212B"/>
                 </a:solidFill>
@@ -7301,14 +7301,14 @@
           <a:p xmlns:a="http://schemas.openxmlformats.org/drawingml/2006/main">
             <a:pPr algn="l">
               <a:buNone/>
-              <a:defRPr sz="1350" b="1" i="0">
-                <a:solidFill>
-                  <a:srgbClr val="17212B"/>
-                </a:solidFill>
-              </a:defRPr>
-            </a:pPr>
-            <a:r>
-              <a:rPr sz="1350" b="1" i="0">
+              <a:defRPr sz="1275" b="1" i="0">
+                <a:solidFill>
+                  <a:srgbClr val="17212B"/>
+                </a:solidFill>
+              </a:defRPr>
+            </a:pPr>
+            <a:r>
+              <a:rPr sz="1275" b="1" i="0">
                 <a:solidFill>
                   <a:srgbClr val="17212B"/>
                 </a:solidFill>
@@ -7352,14 +7352,14 @@
           <a:p xmlns:a="http://schemas.openxmlformats.org/drawingml/2006/main">
             <a:pPr algn="l">
               <a:buNone/>
-              <a:defRPr sz="1275" b="1" i="0">
+              <a:defRPr sz="1200" b="1" i="0">
                 <a:solidFill>
                   <a:srgbClr val="16785B"/>
                 </a:solidFill>
               </a:defRPr>
             </a:pPr>
             <a:r>
-              <a:rPr sz="1275" b="1" i="0">
+              <a:rPr sz="1200" b="1" i="0">
                 <a:solidFill>
                   <a:srgbClr val="16785B"/>
                 </a:solidFill>
@@ -7403,14 +7403,14 @@
           <a:p xmlns:a="http://schemas.openxmlformats.org/drawingml/2006/main">
             <a:pPr algn="l">
               <a:buNone/>
-              <a:defRPr sz="1275" b="0" i="0">
-                <a:solidFill>
-                  <a:srgbClr val="17212B"/>
-                </a:solidFill>
-              </a:defRPr>
-            </a:pPr>
-            <a:r>
-              <a:rPr sz="1275" b="0" i="0">
+              <a:defRPr sz="1200" b="0" i="0">
+                <a:solidFill>
+                  <a:srgbClr val="17212B"/>
+                </a:solidFill>
+              </a:defRPr>
+            </a:pPr>
+            <a:r>
+              <a:rPr sz="1200" b="0" i="0">
                 <a:solidFill>
                   <a:srgbClr val="17212B"/>
                 </a:solidFill>
@@ -7487,14 +7487,14 @@
           <a:p xmlns:a="http://schemas.openxmlformats.org/drawingml/2006/main">
             <a:pPr algn="l">
               <a:buNone/>
-              <a:defRPr sz="1350" b="1" i="0">
-                <a:solidFill>
-                  <a:srgbClr val="17212B"/>
-                </a:solidFill>
-              </a:defRPr>
-            </a:pPr>
-            <a:r>
-              <a:rPr sz="1350" b="1" i="0">
+              <a:defRPr sz="1275" b="1" i="0">
+                <a:solidFill>
+                  <a:srgbClr val="17212B"/>
+                </a:solidFill>
+              </a:defRPr>
+            </a:pPr>
+            <a:r>
+              <a:rPr sz="1275" b="1" i="0">
                 <a:solidFill>
                   <a:srgbClr val="17212B"/>
                 </a:solidFill>
@@ -7538,14 +7538,14 @@
           <a:p xmlns:a="http://schemas.openxmlformats.org/drawingml/2006/main">
             <a:pPr algn="l">
               <a:buNone/>
-              <a:defRPr sz="1275" b="1" i="0">
+              <a:defRPr sz="1200" b="1" i="0">
                 <a:solidFill>
                   <a:srgbClr val="16785B"/>
                 </a:solidFill>
               </a:defRPr>
             </a:pPr>
             <a:r>
-              <a:rPr sz="1275" b="1" i="0">
+              <a:rPr sz="1200" b="1" i="0">
                 <a:solidFill>
                   <a:srgbClr val="16785B"/>
                 </a:solidFill>
@@ -7589,14 +7589,14 @@
           <a:p xmlns:a="http://schemas.openxmlformats.org/drawingml/2006/main">
             <a:pPr algn="l">
               <a:buNone/>
-              <a:defRPr sz="1275" b="0" i="0">
-                <a:solidFill>
-                  <a:srgbClr val="17212B"/>
-                </a:solidFill>
-              </a:defRPr>
-            </a:pPr>
-            <a:r>
-              <a:rPr sz="1275" b="0" i="0">
+              <a:defRPr sz="1200" b="0" i="0">
+                <a:solidFill>
+                  <a:srgbClr val="17212B"/>
+                </a:solidFill>
+              </a:defRPr>
+            </a:pPr>
+            <a:r>
+              <a:rPr sz="1200" b="0" i="0">
                 <a:solidFill>
                   <a:srgbClr val="17212B"/>
                 </a:solidFill>
@@ -7673,14 +7673,14 @@
           <a:p xmlns:a="http://schemas.openxmlformats.org/drawingml/2006/main">
             <a:pPr algn="l">
               <a:buNone/>
-              <a:defRPr sz="1350" b="1" i="0">
-                <a:solidFill>
-                  <a:srgbClr val="17212B"/>
-                </a:solidFill>
-              </a:defRPr>
-            </a:pPr>
-            <a:r>
-              <a:rPr sz="1350" b="1" i="0">
+              <a:defRPr sz="1275" b="1" i="0">
+                <a:solidFill>
+                  <a:srgbClr val="17212B"/>
+                </a:solidFill>
+              </a:defRPr>
+            </a:pPr>
+            <a:r>
+              <a:rPr sz="1275" b="1" i="0">
                 <a:solidFill>
                   <a:srgbClr val="17212B"/>
                 </a:solidFill>
@@ -7724,14 +7724,14 @@
           <a:p xmlns:a="http://schemas.openxmlformats.org/drawingml/2006/main">
             <a:pPr algn="l">
               <a:buNone/>
-              <a:defRPr sz="1275" b="1" i="0">
+              <a:defRPr sz="1200" b="1" i="0">
                 <a:solidFill>
                   <a:srgbClr val="16785B"/>
                 </a:solidFill>
               </a:defRPr>
             </a:pPr>
             <a:r>
-              <a:rPr sz="1275" b="1" i="0">
+              <a:rPr sz="1200" b="1" i="0">
                 <a:solidFill>
                   <a:srgbClr val="16785B"/>
                 </a:solidFill>
@@ -7775,14 +7775,14 @@
           <a:p xmlns:a="http://schemas.openxmlformats.org/drawingml/2006/main">
             <a:pPr algn="l">
               <a:buNone/>
-              <a:defRPr sz="1275" b="0" i="0">
-                <a:solidFill>
-                  <a:srgbClr val="17212B"/>
-                </a:solidFill>
-              </a:defRPr>
-            </a:pPr>
-            <a:r>
-              <a:rPr sz="1275" b="0" i="0">
+              <a:defRPr sz="1200" b="0" i="0">
+                <a:solidFill>
+                  <a:srgbClr val="17212B"/>
+                </a:solidFill>
+              </a:defRPr>
+            </a:pPr>
+            <a:r>
+              <a:rPr sz="1200" b="0" i="0">
                 <a:solidFill>
                   <a:srgbClr val="17212B"/>
                 </a:solidFill>
@@ -7859,14 +7859,14 @@
           <a:p xmlns:a="http://schemas.openxmlformats.org/drawingml/2006/main">
             <a:pPr algn="l">
               <a:buNone/>
-              <a:defRPr sz="1350" b="1" i="0">
-                <a:solidFill>
-                  <a:srgbClr val="17212B"/>
-                </a:solidFill>
-              </a:defRPr>
-            </a:pPr>
-            <a:r>
-              <a:rPr sz="1350" b="1" i="0">
+              <a:defRPr sz="1275" b="1" i="0">
+                <a:solidFill>
+                  <a:srgbClr val="17212B"/>
+                </a:solidFill>
+              </a:defRPr>
+            </a:pPr>
+            <a:r>
+              <a:rPr sz="1275" b="1" i="0">
                 <a:solidFill>
                   <a:srgbClr val="17212B"/>
                 </a:solidFill>
@@ -7910,14 +7910,14 @@
           <a:p xmlns:a="http://schemas.openxmlformats.org/drawingml/2006/main">
             <a:pPr algn="l">
               <a:buNone/>
-              <a:defRPr sz="1275" b="1" i="0">
+              <a:defRPr sz="1200" b="1" i="0">
                 <a:solidFill>
                   <a:srgbClr val="16785B"/>
                 </a:solidFill>
               </a:defRPr>
             </a:pPr>
             <a:r>
-              <a:rPr sz="1275" b="1" i="0">
+              <a:rPr sz="1200" b="1" i="0">
                 <a:solidFill>
                   <a:srgbClr val="16785B"/>
                 </a:solidFill>
@@ -7961,14 +7961,14 @@
           <a:p xmlns:a="http://schemas.openxmlformats.org/drawingml/2006/main">
             <a:pPr algn="l">
               <a:buNone/>
-              <a:defRPr sz="1275" b="0" i="0">
-                <a:solidFill>
-                  <a:srgbClr val="17212B"/>
-                </a:solidFill>
-              </a:defRPr>
-            </a:pPr>
-            <a:r>
-              <a:rPr sz="1275" b="0" i="0">
+              <a:defRPr sz="1200" b="0" i="0">
+                <a:solidFill>
+                  <a:srgbClr val="17212B"/>
+                </a:solidFill>
+              </a:defRPr>
+            </a:pPr>
+            <a:r>
+              <a:rPr sz="1200" b="0" i="0">
                 <a:solidFill>
                   <a:srgbClr val="17212B"/>
                 </a:solidFill>
@@ -8176,14 +8176,14 @@
           <a:p xmlns:a="http://schemas.openxmlformats.org/drawingml/2006/main">
             <a:pPr algn="l">
               <a:buNone/>
-              <a:defRPr sz="3600" b="1" i="0">
-                <a:solidFill>
-                  <a:srgbClr val="17212B"/>
-                </a:solidFill>
-              </a:defRPr>
-            </a:pPr>
-            <a:r>
-              <a:rPr sz="3600" b="1" i="0">
+              <a:defRPr sz="3000" b="1" i="0">
+                <a:solidFill>
+                  <a:srgbClr val="17212B"/>
+                </a:solidFill>
+              </a:defRPr>
+            </a:pPr>
+            <a:r>
+              <a:rPr sz="3000" b="1" i="0">
                 <a:solidFill>
                   <a:srgbClr val="17212B"/>
                 </a:solidFill>
@@ -9570,14 +9570,14 @@
           <a:p xmlns:a="http://schemas.openxmlformats.org/drawingml/2006/main">
             <a:pPr algn="l">
               <a:buNone/>
-              <a:defRPr sz="3600" b="1" i="0">
-                <a:solidFill>
-                  <a:srgbClr val="17212B"/>
-                </a:solidFill>
-              </a:defRPr>
-            </a:pPr>
-            <a:r>
-              <a:rPr sz="3600" b="1" i="0">
+              <a:defRPr sz="3000" b="1" i="0">
+                <a:solidFill>
+                  <a:srgbClr val="17212B"/>
+                </a:solidFill>
+              </a:defRPr>
+            </a:pPr>
+            <a:r>
+              <a:rPr sz="3000" b="1" i="0">
                 <a:solidFill>
                   <a:srgbClr val="17212B"/>
                 </a:solidFill>
@@ -10520,14 +10520,14 @@
           <a:p xmlns:a="http://schemas.openxmlformats.org/drawingml/2006/main">
             <a:pPr algn="l">
               <a:buNone/>
-              <a:defRPr sz="3600" b="1" i="0">
-                <a:solidFill>
-                  <a:srgbClr val="17212B"/>
-                </a:solidFill>
-              </a:defRPr>
-            </a:pPr>
-            <a:r>
-              <a:rPr sz="3600" b="1" i="0">
+              <a:defRPr sz="3000" b="1" i="0">
+                <a:solidFill>
+                  <a:srgbClr val="17212B"/>
+                </a:solidFill>
+              </a:defRPr>
+            </a:pPr>
+            <a:r>
+              <a:rPr sz="3000" b="1" i="0">
                 <a:solidFill>
                   <a:srgbClr val="17212B"/>
                 </a:solidFill>
@@ -11236,14 +11236,14 @@
           <a:p xmlns:a="http://schemas.openxmlformats.org/drawingml/2006/main">
             <a:pPr algn="l">
               <a:buNone/>
-              <a:defRPr sz="3600" b="1" i="0">
-                <a:solidFill>
-                  <a:srgbClr val="17212B"/>
-                </a:solidFill>
-              </a:defRPr>
-            </a:pPr>
-            <a:r>
-              <a:rPr sz="3600" b="1" i="0">
+              <a:defRPr sz="3000" b="1" i="0">
+                <a:solidFill>
+                  <a:srgbClr val="17212B"/>
+                </a:solidFill>
+              </a:defRPr>
+            </a:pPr>
+            <a:r>
+              <a:rPr sz="3000" b="1" i="0">
                 <a:solidFill>
                   <a:srgbClr val="17212B"/>
                 </a:solidFill>
@@ -12009,14 +12009,14 @@
           <a:p xmlns:a="http://schemas.openxmlformats.org/drawingml/2006/main">
             <a:pPr algn="l">
               <a:buNone/>
-              <a:defRPr sz="3600" b="1" i="0">
-                <a:solidFill>
-                  <a:srgbClr val="17212B"/>
-                </a:solidFill>
-              </a:defRPr>
-            </a:pPr>
-            <a:r>
-              <a:rPr sz="3600" b="1" i="0">
+              <a:defRPr sz="3000" b="1" i="0">
+                <a:solidFill>
+                  <a:srgbClr val="17212B"/>
+                </a:solidFill>
+              </a:defRPr>
+            </a:pPr>
+            <a:r>
+              <a:rPr sz="3000" b="1" i="0">
                 <a:solidFill>
                   <a:srgbClr val="17212B"/>
                 </a:solidFill>
@@ -12635,14 +12635,14 @@
           <a:p xmlns:a="http://schemas.openxmlformats.org/drawingml/2006/main">
             <a:pPr algn="l">
               <a:buNone/>
-              <a:defRPr sz="3600" b="1" i="0">
-                <a:solidFill>
-                  <a:srgbClr val="17212B"/>
-                </a:solidFill>
-              </a:defRPr>
-            </a:pPr>
-            <a:r>
-              <a:rPr sz="3600" b="1" i="0">
+              <a:defRPr sz="3000" b="1" i="0">
+                <a:solidFill>
+                  <a:srgbClr val="17212B"/>
+                </a:solidFill>
+              </a:defRPr>
+            </a:pPr>
+            <a:r>
+              <a:rPr sz="3000" b="1" i="0">
                 <a:solidFill>
                   <a:srgbClr val="17212B"/>
                 </a:solidFill>
@@ -13294,14 +13294,14 @@
           <a:p xmlns:a="http://schemas.openxmlformats.org/drawingml/2006/main">
             <a:pPr algn="l">
               <a:buNone/>
-              <a:defRPr sz="3600" b="1" i="0">
-                <a:solidFill>
-                  <a:srgbClr val="17212B"/>
-                </a:solidFill>
-              </a:defRPr>
-            </a:pPr>
-            <a:r>
-              <a:rPr sz="3600" b="1" i="0">
+              <a:defRPr sz="3000" b="1" i="0">
+                <a:solidFill>
+                  <a:srgbClr val="17212B"/>
+                </a:solidFill>
+              </a:defRPr>
+            </a:pPr>
+            <a:r>
+              <a:rPr sz="3000" b="1" i="0">
                 <a:solidFill>
                   <a:srgbClr val="17212B"/>
                 </a:solidFill>
@@ -14655,14 +14655,14 @@
           <a:p xmlns:a="http://schemas.openxmlformats.org/drawingml/2006/main">
             <a:pPr algn="l">
               <a:buNone/>
-              <a:defRPr sz="3600" b="1" i="0">
-                <a:solidFill>
-                  <a:srgbClr val="17212B"/>
-                </a:solidFill>
-              </a:defRPr>
-            </a:pPr>
-            <a:r>
-              <a:rPr sz="3600" b="1" i="0">
+              <a:defRPr sz="3000" b="1" i="0">
+                <a:solidFill>
+                  <a:srgbClr val="17212B"/>
+                </a:solidFill>
+              </a:defRPr>
+            </a:pPr>
+            <a:r>
+              <a:rPr sz="3000" b="1" i="0">
                 <a:solidFill>
                   <a:srgbClr val="17212B"/>
                 </a:solidFill>
@@ -15246,14 +15246,14 @@
           <a:p xmlns:a="http://schemas.openxmlformats.org/drawingml/2006/main">
             <a:pPr algn="l">
               <a:buNone/>
-              <a:defRPr sz="1650" b="1" i="0">
+              <a:defRPr sz="1500" b="1" i="0">
                 <a:solidFill>
                   <a:srgbClr val="0F5F49"/>
                 </a:solidFill>
               </a:defRPr>
             </a:pPr>
             <a:r>
-              <a:rPr sz="1650" b="1" i="0">
+              <a:rPr sz="1500" b="1" i="0">
                 <a:solidFill>
                   <a:srgbClr val="0F5F49"/>
                 </a:solidFill>
@@ -16088,14 +16088,14 @@
           <a:p xmlns:a="http://schemas.openxmlformats.org/drawingml/2006/main">
             <a:pPr algn="l">
               <a:buNone/>
-              <a:defRPr sz="3600" b="1" i="0">
-                <a:solidFill>
-                  <a:srgbClr val="17212B"/>
-                </a:solidFill>
-              </a:defRPr>
-            </a:pPr>
-            <a:r>
-              <a:rPr sz="3600" b="1" i="0">
+              <a:defRPr sz="3000" b="1" i="0">
+                <a:solidFill>
+                  <a:srgbClr val="17212B"/>
+                </a:solidFill>
+              </a:defRPr>
+            </a:pPr>
+            <a:r>
+              <a:rPr sz="3000" b="1" i="0">
                 <a:solidFill>
                   <a:srgbClr val="17212B"/>
                 </a:solidFill>
@@ -17131,14 +17131,14 @@
           <a:p xmlns:a="http://schemas.openxmlformats.org/drawingml/2006/main">
             <a:pPr algn="l">
               <a:buNone/>
-              <a:defRPr sz="3600" b="1" i="0">
-                <a:solidFill>
-                  <a:srgbClr val="17212B"/>
-                </a:solidFill>
-              </a:defRPr>
-            </a:pPr>
-            <a:r>
-              <a:rPr sz="3600" b="1" i="0">
+              <a:defRPr sz="3000" b="1" i="0">
+                <a:solidFill>
+                  <a:srgbClr val="17212B"/>
+                </a:solidFill>
+              </a:defRPr>
+            </a:pPr>
+            <a:r>
+              <a:rPr sz="3000" b="1" i="0">
                 <a:solidFill>
                   <a:srgbClr val="17212B"/>
                 </a:solidFill>
@@ -17317,14 +17317,14 @@
           <a:p xmlns:a="http://schemas.openxmlformats.org/drawingml/2006/main">
             <a:pPr algn="l">
               <a:buNone/>
-              <a:defRPr sz="2100" b="1" i="0">
-                <a:solidFill>
-                  <a:srgbClr val="17212B"/>
-                </a:solidFill>
-              </a:defRPr>
-            </a:pPr>
-            <a:r>
-              <a:rPr sz="2100" b="1" i="0">
+              <a:defRPr sz="1800" b="1" i="0">
+                <a:solidFill>
+                  <a:srgbClr val="17212B"/>
+                </a:solidFill>
+              </a:defRPr>
+            </a:pPr>
+            <a:r>
+              <a:rPr sz="1800" b="1" i="0">
                 <a:solidFill>
                   <a:srgbClr val="17212B"/>
                 </a:solidFill>
@@ -18312,14 +18312,14 @@
           <a:p xmlns:a="http://schemas.openxmlformats.org/drawingml/2006/main">
             <a:pPr algn="l">
               <a:buNone/>
-              <a:defRPr sz="3600" b="1" i="0">
-                <a:solidFill>
-                  <a:srgbClr val="17212B"/>
-                </a:solidFill>
-              </a:defRPr>
-            </a:pPr>
-            <a:r>
-              <a:rPr sz="3600" b="1" i="0">
+              <a:defRPr sz="3000" b="1" i="0">
+                <a:solidFill>
+                  <a:srgbClr val="17212B"/>
+                </a:solidFill>
+              </a:defRPr>
+            </a:pPr>
+            <a:r>
+              <a:rPr sz="3000" b="1" i="0">
                 <a:solidFill>
                   <a:srgbClr val="17212B"/>
                 </a:solidFill>
@@ -19793,14 +19793,14 @@
           <a:p xmlns:a="http://schemas.openxmlformats.org/drawingml/2006/main">
             <a:pPr algn="l">
               <a:buNone/>
-              <a:defRPr sz="3600" b="1" i="0">
-                <a:solidFill>
-                  <a:srgbClr val="17212B"/>
-                </a:solidFill>
-              </a:defRPr>
-            </a:pPr>
-            <a:r>
-              <a:rPr sz="3600" b="1" i="0">
+              <a:defRPr sz="3000" b="1" i="0">
+                <a:solidFill>
+                  <a:srgbClr val="17212B"/>
+                </a:solidFill>
+              </a:defRPr>
+            </a:pPr>
+            <a:r>
+              <a:rPr sz="3000" b="1" i="0">
                 <a:solidFill>
                   <a:srgbClr val="17212B"/>
                 </a:solidFill>
@@ -21766,14 +21766,14 @@
           <a:p xmlns:a="http://schemas.openxmlformats.org/drawingml/2006/main">
             <a:pPr algn="l">
               <a:buNone/>
-              <a:defRPr sz="3600" b="1" i="0">
-                <a:solidFill>
-                  <a:srgbClr val="17212B"/>
-                </a:solidFill>
-              </a:defRPr>
-            </a:pPr>
-            <a:r>
-              <a:rPr sz="3600" b="1" i="0">
+              <a:defRPr sz="3000" b="1" i="0">
+                <a:solidFill>
+                  <a:srgbClr val="17212B"/>
+                </a:solidFill>
+              </a:defRPr>
+            </a:pPr>
+            <a:r>
+              <a:rPr sz="3000" b="1" i="0">
                 <a:solidFill>
                   <a:srgbClr val="17212B"/>
                 </a:solidFill>

</xml_diff>